<commit_message>
Update 인간 제로 assets and add ZIP slides
Co-Authored-By: Claude Opus 4.6 (1M context) <noreply@anthropic.com>
</commit_message>
<xml_diff>
--- a/public/downloads/games/human-zero/rules.pptx
+++ b/public/downloads/games/human-zero/rules.pptx
@@ -15,16 +15,12 @@
   <p:notesSz cx="6858000" cy="9144000"/>
   <p:embeddedFontLst>
     <p:embeddedFont>
-      <p:font typeface="Jua" charset="1" panose="00000000000000000000"/>
+      <p:font typeface="무궁화 고딕" charset="1" panose="02020603020101020101"/>
       <p:regular r:id="rId11"/>
     </p:embeddedFont>
     <p:embeddedFont>
-      <p:font typeface="TDTD갬성명조" charset="1" panose="02000503000000000000"/>
+      <p:font typeface="무궁화 고딕 Bold" charset="1" panose="02020603020101020101"/>
       <p:regular r:id="rId12"/>
-    </p:embeddedFont>
-    <p:embeddedFont>
-      <p:font typeface="TDTD가온" charset="1" panose="02000503000000000000"/>
-      <p:regular r:id="rId13"/>
     </p:embeddedFont>
   </p:embeddedFontLst>
   <p:defaultTextStyle>
@@ -3142,8 +3138,8 @@
         </p:nvSpPr>
         <p:spPr>
           <a:xfrm rot="0">
-            <a:off x="1028700" y="3892867"/>
-            <a:ext cx="15555091" cy="2200275"/>
+            <a:off x="1028700" y="4178617"/>
+            <a:ext cx="15555091" cy="1914525"/>
           </a:xfrm>
           <a:prstGeom prst="rect">
             <a:avLst/>
@@ -3165,10 +3161,10 @@
                 <a:solidFill>
                   <a:srgbClr val="FFFAEF"/>
                 </a:solidFill>
-                <a:latin typeface="Jua"/>
-                <a:ea typeface="Jua"/>
-                <a:cs typeface="Jua"/>
-                <a:sym typeface="Jua"/>
+                <a:latin typeface="무궁화 고딕"/>
+                <a:ea typeface="무궁화 고딕"/>
+                <a:cs typeface="무궁화 고딕"/>
+                <a:sym typeface="무궁화 고딕"/>
               </a:rPr>
               <a:t>인간 제로</a:t>
             </a:r>
@@ -3183,8 +3179,8 @@
         </p:nvSpPr>
         <p:spPr>
           <a:xfrm rot="0">
-            <a:off x="15264803" y="9812655"/>
-            <a:ext cx="2637975" cy="474345"/>
+            <a:off x="14302277" y="9822180"/>
+            <a:ext cx="3600502" cy="464820"/>
           </a:xfrm>
           <a:prstGeom prst="rect">
             <a:avLst/>
@@ -3209,10 +3205,10 @@
                 <a:solidFill>
                   <a:srgbClr val="FFFFFF"/>
                 </a:solidFill>
-                <a:latin typeface="TDTD갬성명조"/>
-                <a:ea typeface="TDTD갬성명조"/>
-                <a:cs typeface="TDTD갬성명조"/>
-                <a:sym typeface="TDTD갬성명조"/>
+                <a:latin typeface="무궁화 고딕"/>
+                <a:ea typeface="무궁화 고딕"/>
+                <a:cs typeface="무궁화 고딕"/>
+                <a:sym typeface="무궁화 고딕"/>
               </a:rPr>
               <a:t>ⓒ 2026. Sunday Play</a:t>
             </a:r>
@@ -3361,8 +3357,8 @@
         </p:nvSpPr>
         <p:spPr>
           <a:xfrm rot="0">
-            <a:off x="11392761" y="600705"/>
-            <a:ext cx="5362043" cy="1600200"/>
+            <a:off x="11392761" y="819780"/>
+            <a:ext cx="5362043" cy="1381125"/>
           </a:xfrm>
           <a:prstGeom prst="rect">
             <a:avLst/>
@@ -3384,10 +3380,10 @@
                 <a:solidFill>
                   <a:srgbClr val="FFFAEF"/>
                 </a:solidFill>
-                <a:latin typeface="Jua"/>
-                <a:ea typeface="Jua"/>
-                <a:cs typeface="Jua"/>
-                <a:sym typeface="Jua"/>
+                <a:latin typeface="무궁화 고딕"/>
+                <a:ea typeface="무궁화 고딕"/>
+                <a:cs typeface="무궁화 고딕"/>
+                <a:sym typeface="무궁화 고딕"/>
               </a:rPr>
               <a:t>규칙</a:t>
             </a:r>
@@ -3403,9 +3399,9 @@
         <p:grpSpPr>
           <a:xfrm rot="0">
             <a:off x="309172" y="535073"/>
-            <a:ext cx="12078314" cy="1779769"/>
+            <a:ext cx="12078314" cy="1701684"/>
             <a:chOff x="0" y="0"/>
-            <a:chExt cx="16104419" cy="2373026"/>
+            <a:chExt cx="16104419" cy="2268911"/>
           </a:xfrm>
         </p:grpSpPr>
         <p:sp>
@@ -3416,8 +3412,8 @@
           </p:nvSpPr>
           <p:spPr>
             <a:xfrm rot="0">
-              <a:off x="0" y="1380584"/>
-              <a:ext cx="16104419" cy="992442"/>
+              <a:off x="0" y="1388378"/>
+              <a:ext cx="16104419" cy="880533"/>
             </a:xfrm>
             <a:prstGeom prst="rect">
               <a:avLst/>
@@ -3431,30 +3427,30 @@
             <a:p>
               <a:pPr algn="l">
                 <a:lnSpc>
-                  <a:spcPts val="6273"/>
+                  <a:spcPts val="5599"/>
                 </a:lnSpc>
               </a:pPr>
               <a:r>
-                <a:rPr lang="en-US" sz="4480">
+                <a:rPr lang="en-US" sz="3999">
                   <a:solidFill>
                     <a:srgbClr val="FFFAEF"/>
                   </a:solidFill>
-                  <a:latin typeface="TDTD가온"/>
-                  <a:ea typeface="TDTD가온"/>
-                  <a:cs typeface="TDTD가온"/>
-                  <a:sym typeface="TDTD가온"/>
+                  <a:latin typeface="무궁화 고딕"/>
+                  <a:ea typeface="무궁화 고딕"/>
+                  <a:cs typeface="무궁화 고딕"/>
+                  <a:sym typeface="무궁화 고딕"/>
                 </a:rPr>
                 <a:t>2팀으로 나눠</a:t>
               </a:r>
               <a:r>
-                <a:rPr lang="en-US" sz="4480">
+                <a:rPr lang="en-US" sz="3999">
                   <a:solidFill>
                     <a:srgbClr val="FFFAEF"/>
                   </a:solidFill>
-                  <a:latin typeface="TDTD가온"/>
-                  <a:ea typeface="TDTD가온"/>
-                  <a:cs typeface="TDTD가온"/>
-                  <a:sym typeface="TDTD가온"/>
+                  <a:latin typeface="무궁화 고딕"/>
+                  <a:ea typeface="무궁화 고딕"/>
+                  <a:cs typeface="무궁화 고딕"/>
+                  <a:sym typeface="무궁화 고딕"/>
                 </a:rPr>
                 <a:t> 앉습니다. (팀당 4~5명) </a:t>
               </a:r>
@@ -3469,8 +3465,8 @@
           </p:nvSpPr>
           <p:spPr>
             <a:xfrm rot="0">
-              <a:off x="0" y="-171450"/>
-              <a:ext cx="9574913" cy="1169217"/>
+              <a:off x="0" y="-66675"/>
+              <a:ext cx="9574913" cy="1062712"/>
             </a:xfrm>
             <a:prstGeom prst="rect">
               <a:avLst/>
@@ -3492,10 +3488,10 @@
                   <a:solidFill>
                     <a:srgbClr val="FFFAEF"/>
                   </a:solidFill>
-                  <a:latin typeface="Jua"/>
-                  <a:ea typeface="Jua"/>
-                  <a:cs typeface="Jua"/>
-                  <a:sym typeface="Jua"/>
+                  <a:latin typeface="무궁화 고딕 Bold"/>
+                  <a:ea typeface="무궁화 고딕 Bold"/>
+                  <a:cs typeface="무궁화 고딕 Bold"/>
+                  <a:sym typeface="무궁화 고딕 Bold"/>
                 </a:rPr>
                 <a:t>STEP 1.</a:t>
               </a:r>
@@ -3511,10 +3507,10 @@
         </p:nvGrpSpPr>
         <p:grpSpPr>
           <a:xfrm rot="0">
-            <a:off x="11392761" y="8200435"/>
-            <a:ext cx="6500470" cy="1778769"/>
+            <a:off x="11192234" y="8200435"/>
+            <a:ext cx="6700996" cy="1697863"/>
             <a:chOff x="0" y="0"/>
-            <a:chExt cx="8667293" cy="2371692"/>
+            <a:chExt cx="8934662" cy="2263817"/>
           </a:xfrm>
         </p:grpSpPr>
         <p:sp>
@@ -3525,8 +3521,8 @@
           </p:nvSpPr>
           <p:spPr>
             <a:xfrm rot="0">
-              <a:off x="0" y="1377534"/>
-              <a:ext cx="8534787" cy="994158"/>
+              <a:off x="0" y="1383283"/>
+              <a:ext cx="8798067" cy="880533"/>
             </a:xfrm>
             <a:prstGeom prst="rect">
               <a:avLst/>
@@ -3540,30 +3536,30 @@
             <a:p>
               <a:pPr algn="l">
                 <a:lnSpc>
-                  <a:spcPts val="6284"/>
+                  <a:spcPts val="5599"/>
                 </a:lnSpc>
               </a:pPr>
               <a:r>
-                <a:rPr lang="en-US" sz="4489">
+                <a:rPr lang="en-US" sz="3999">
                   <a:solidFill>
                     <a:srgbClr val="FFFAEF"/>
                   </a:solidFill>
-                  <a:latin typeface="TDTD가온"/>
-                  <a:ea typeface="TDTD가온"/>
-                  <a:cs typeface="TDTD가온"/>
-                  <a:sym typeface="TDTD가온"/>
+                  <a:latin typeface="무궁화 고딕"/>
+                  <a:ea typeface="무궁화 고딕"/>
+                  <a:cs typeface="무궁화 고딕"/>
+                  <a:sym typeface="무궁화 고딕"/>
                 </a:rPr>
                 <a:t>먼저 3회 공격 성공한</a:t>
               </a:r>
               <a:r>
-                <a:rPr lang="en-US" sz="4489">
+                <a:rPr lang="en-US" sz="3999">
                   <a:solidFill>
                     <a:srgbClr val="FFFAEF"/>
                   </a:solidFill>
-                  <a:latin typeface="TDTD가온"/>
-                  <a:ea typeface="TDTD가온"/>
-                  <a:cs typeface="TDTD가온"/>
-                  <a:sym typeface="TDTD가온"/>
+                  <a:latin typeface="무궁화 고딕"/>
+                  <a:ea typeface="무궁화 고딕"/>
+                  <a:cs typeface="무궁화 고딕"/>
+                  <a:sym typeface="무궁화 고딕"/>
                 </a:rPr>
                 <a:t> 팀이 승리!</a:t>
               </a:r>
@@ -3578,8 +3574,8 @@
           </p:nvSpPr>
           <p:spPr>
             <a:xfrm rot="0">
-              <a:off x="0" y="-171450"/>
-              <a:ext cx="8667293" cy="1171105"/>
+              <a:off x="0" y="-57150"/>
+              <a:ext cx="8934662" cy="1053029"/>
             </a:xfrm>
             <a:prstGeom prst="rect">
               <a:avLst/>
@@ -3601,10 +3597,10 @@
                   <a:solidFill>
                     <a:srgbClr val="FFFAEF"/>
                   </a:solidFill>
-                  <a:latin typeface="Jua"/>
-                  <a:ea typeface="Jua"/>
-                  <a:cs typeface="Jua"/>
-                  <a:sym typeface="Jua"/>
+                  <a:latin typeface="무궁화 고딕 Bold"/>
+                  <a:ea typeface="무궁화 고딕 Bold"/>
+                  <a:cs typeface="무궁화 고딕 Bold"/>
+                  <a:sym typeface="무궁화 고딕 Bold"/>
                 </a:rPr>
                 <a:t>STEP 3.</a:t>
               </a:r>
@@ -3620,10 +3616,10 @@
         </p:nvGrpSpPr>
         <p:grpSpPr>
           <a:xfrm rot="0">
-            <a:off x="4155738" y="3178521"/>
-            <a:ext cx="11500525" cy="4158235"/>
+            <a:off x="4195843" y="3312615"/>
+            <a:ext cx="11500525" cy="3811961"/>
             <a:chOff x="0" y="0"/>
-            <a:chExt cx="15334033" cy="5544313"/>
+            <a:chExt cx="15334033" cy="5082615"/>
           </a:xfrm>
         </p:grpSpPr>
         <p:sp>
@@ -3634,8 +3630,8 @@
           </p:nvSpPr>
           <p:spPr>
             <a:xfrm rot="0">
-              <a:off x="0" y="1375218"/>
-              <a:ext cx="15334033" cy="4169095"/>
+              <a:off x="0" y="1382681"/>
+              <a:ext cx="15334033" cy="3699933"/>
             </a:xfrm>
             <a:prstGeom prst="rect">
               <a:avLst/>
@@ -3649,18 +3645,18 @@
             <a:p>
               <a:pPr algn="l">
                 <a:lnSpc>
-                  <a:spcPts val="6275"/>
+                  <a:spcPts val="5599"/>
                 </a:lnSpc>
               </a:pPr>
               <a:r>
-                <a:rPr lang="en-US" sz="4482">
+                <a:rPr lang="en-US" sz="3999">
                   <a:solidFill>
                     <a:srgbClr val="FFFAEF"/>
                   </a:solidFill>
-                  <a:latin typeface="TDTD가온"/>
-                  <a:ea typeface="TDTD가온"/>
-                  <a:cs typeface="TDTD가온"/>
-                  <a:sym typeface="TDTD가온"/>
+                  <a:latin typeface="무궁화 고딕"/>
+                  <a:ea typeface="무궁화 고딕"/>
+                  <a:cs typeface="무궁화 고딕"/>
+                  <a:sym typeface="무궁화 고딕"/>
                 </a:rPr>
                 <a:t>공격팀이 0~상대 인원수 중 숫자를 외칩니다.                                    </a:t>
               </a:r>
@@ -3668,18 +3664,18 @@
             <a:p>
               <a:pPr algn="l">
                 <a:lnSpc>
-                  <a:spcPts val="6275"/>
+                  <a:spcPts val="5599"/>
                 </a:lnSpc>
               </a:pPr>
               <a:r>
-                <a:rPr lang="en-US" sz="4482">
+                <a:rPr lang="en-US" sz="3999">
                   <a:solidFill>
                     <a:srgbClr val="FFFAEF"/>
                   </a:solidFill>
-                  <a:latin typeface="TDTD가온"/>
-                  <a:ea typeface="TDTD가온"/>
-                  <a:cs typeface="TDTD가온"/>
-                  <a:sym typeface="TDTD가온"/>
+                  <a:latin typeface="무궁화 고딕"/>
+                  <a:ea typeface="무궁화 고딕"/>
+                  <a:cs typeface="무궁화 고딕"/>
+                  <a:sym typeface="무궁화 고딕"/>
                 </a:rPr>
                 <a:t>수비팀은 동시에 일어나거나 앉습니다.                               </a:t>
               </a:r>
@@ -3687,18 +3683,18 @@
             <a:p>
               <a:pPr algn="l">
                 <a:lnSpc>
-                  <a:spcPts val="6275"/>
+                  <a:spcPts val="5599"/>
                 </a:lnSpc>
               </a:pPr>
               <a:r>
-                <a:rPr lang="en-US" sz="4482">
+                <a:rPr lang="en-US" sz="3999">
                   <a:solidFill>
                     <a:srgbClr val="FFFAEF"/>
                   </a:solidFill>
-                  <a:latin typeface="TDTD가온"/>
-                  <a:ea typeface="TDTD가온"/>
-                  <a:cs typeface="TDTD가온"/>
-                  <a:sym typeface="TDTD가온"/>
+                  <a:latin typeface="무궁화 고딕"/>
+                  <a:ea typeface="무궁화 고딕"/>
+                  <a:cs typeface="무궁화 고딕"/>
+                  <a:sym typeface="무궁화 고딕"/>
                 </a:rPr>
                 <a:t>일어난 수 = 부른 숫자면 공격 성공! 한 번 더 공격!                                </a:t>
               </a:r>
@@ -3706,18 +3702,18 @@
             <a:p>
               <a:pPr algn="l">
                 <a:lnSpc>
-                  <a:spcPts val="6275"/>
+                  <a:spcPts val="5599"/>
                 </a:lnSpc>
               </a:pPr>
               <a:r>
-                <a:rPr lang="en-US" sz="4482">
+                <a:rPr lang="en-US" sz="3999">
                   <a:solidFill>
                     <a:srgbClr val="FFFAEF"/>
                   </a:solidFill>
-                  <a:latin typeface="TDTD가온"/>
-                  <a:ea typeface="TDTD가온"/>
-                  <a:cs typeface="TDTD가온"/>
-                  <a:sym typeface="TDTD가온"/>
+                  <a:latin typeface="무궁화 고딕"/>
+                  <a:ea typeface="무궁화 고딕"/>
+                  <a:cs typeface="무궁화 고딕"/>
+                  <a:sym typeface="무궁화 고딕"/>
                 </a:rPr>
                 <a:t>실패하면 공수 교대!</a:t>
               </a:r>
@@ -3732,8 +3728,8 @@
           </p:nvSpPr>
           <p:spPr>
             <a:xfrm rot="0">
-              <a:off x="0" y="-171450"/>
-              <a:ext cx="6898637" cy="1169523"/>
+              <a:off x="0" y="-57150"/>
+              <a:ext cx="6898637" cy="1053161"/>
             </a:xfrm>
             <a:prstGeom prst="rect">
               <a:avLst/>
@@ -3755,10 +3751,10 @@
                   <a:solidFill>
                     <a:srgbClr val="FFFAEF"/>
                   </a:solidFill>
-                  <a:latin typeface="Jua"/>
-                  <a:ea typeface="Jua"/>
-                  <a:cs typeface="Jua"/>
-                  <a:sym typeface="Jua"/>
+                  <a:latin typeface="무궁화 고딕 Bold"/>
+                  <a:ea typeface="무궁화 고딕 Bold"/>
+                  <a:cs typeface="무궁화 고딕 Bold"/>
+                  <a:sym typeface="무궁화 고딕 Bold"/>
                 </a:rPr>
                 <a:t>STEP 2.</a:t>
               </a:r>
@@ -3806,8 +3802,8 @@
         </p:nvSpPr>
         <p:spPr>
           <a:xfrm rot="0">
-            <a:off x="3238925" y="4092795"/>
-            <a:ext cx="11810151" cy="2200275"/>
+            <a:off x="3238925" y="4378545"/>
+            <a:ext cx="11810151" cy="1914525"/>
           </a:xfrm>
           <a:prstGeom prst="rect">
             <a:avLst/>
@@ -3829,10 +3825,10 @@
                 <a:solidFill>
                   <a:srgbClr val="000000"/>
                 </a:solidFill>
-                <a:latin typeface="Jua"/>
-                <a:ea typeface="Jua"/>
-                <a:cs typeface="Jua"/>
-                <a:sym typeface="Jua"/>
+                <a:latin typeface="무궁화 고딕"/>
+                <a:ea typeface="무궁화 고딕"/>
+                <a:cs typeface="무궁화 고딕"/>
+                <a:sym typeface="무궁화 고딕"/>
               </a:rPr>
               <a:t>팀을 나눠주세요!</a:t>
             </a:r>
@@ -3979,8 +3975,8 @@
         </p:nvSpPr>
         <p:spPr>
           <a:xfrm rot="0">
-            <a:off x="1028700" y="3892867"/>
-            <a:ext cx="15555091" cy="2200275"/>
+            <a:off x="1028700" y="4178617"/>
+            <a:ext cx="15555091" cy="1914525"/>
           </a:xfrm>
           <a:prstGeom prst="rect">
             <a:avLst/>
@@ -4002,10 +3998,10 @@
                 <a:solidFill>
                   <a:srgbClr val="FFFAEF"/>
                 </a:solidFill>
-                <a:latin typeface="Jua"/>
-                <a:ea typeface="Jua"/>
-                <a:cs typeface="Jua"/>
-                <a:sym typeface="Jua"/>
+                <a:latin typeface="무궁화 고딕"/>
+                <a:ea typeface="무궁화 고딕"/>
+                <a:cs typeface="무궁화 고딕"/>
+                <a:sym typeface="무궁화 고딕"/>
               </a:rPr>
               <a:t>인간 제로</a:t>
             </a:r>
@@ -4020,8 +4016,8 @@
         </p:nvSpPr>
         <p:spPr>
           <a:xfrm rot="0">
-            <a:off x="15264803" y="9812655"/>
-            <a:ext cx="2637975" cy="474345"/>
+            <a:off x="14302277" y="9822180"/>
+            <a:ext cx="3600502" cy="464820"/>
           </a:xfrm>
           <a:prstGeom prst="rect">
             <a:avLst/>
@@ -4046,10 +4042,10 @@
                 <a:solidFill>
                   <a:srgbClr val="FFFFFF"/>
                 </a:solidFill>
-                <a:latin typeface="TDTD갬성명조"/>
-                <a:ea typeface="TDTD갬성명조"/>
-                <a:cs typeface="TDTD갬성명조"/>
-                <a:sym typeface="TDTD갬성명조"/>
+                <a:latin typeface="무궁화 고딕"/>
+                <a:ea typeface="무궁화 고딕"/>
+                <a:cs typeface="무궁화 고딕"/>
+                <a:sym typeface="무궁화 고딕"/>
               </a:rPr>
               <a:t>ⓒ 2026. Sunday Play</a:t>
             </a:r>
@@ -4121,8 +4117,8 @@
         </p:nvSpPr>
         <p:spPr>
           <a:xfrm rot="0">
-            <a:off x="4421807" y="3895725"/>
-            <a:ext cx="9444385" cy="2200275"/>
+            <a:off x="4421807" y="4181475"/>
+            <a:ext cx="9444385" cy="1914525"/>
           </a:xfrm>
           <a:prstGeom prst="rect">
             <a:avLst/>
@@ -4144,10 +4140,10 @@
                 <a:solidFill>
                   <a:srgbClr val="000000"/>
                 </a:solidFill>
-                <a:latin typeface="Jua"/>
-                <a:ea typeface="Jua"/>
-                <a:cs typeface="Jua"/>
-                <a:sym typeface="Jua"/>
+                <a:latin typeface="무궁화 고딕"/>
+                <a:ea typeface="무궁화 고딕"/>
+                <a:cs typeface="무궁화 고딕"/>
+                <a:sym typeface="무궁화 고딕"/>
               </a:rPr>
               <a:t>감사합니다!</a:t>
             </a:r>

</xml_diff>